<commit_message>
Make PPTX presentation more dense with info, adding all metrics, parameters, mathematical formulas, and class-wise details
</commit_message>
<xml_diff>
--- a/Projects/final_project/presentation/presentation.pptx
+++ b/Projects/final_project/presentation/presentation.pptx
@@ -3110,7 +3110,7 @@
         </p:nvSpPr>
         <p:spPr>
           <a:xfrm>
-            <a:off x="640080" y="2011680"/>
+            <a:off x="640080" y="1645920"/>
             <a:ext cx="10881360" cy="365760"/>
           </a:xfrm>
           <a:prstGeom prst="rect">
@@ -3146,7 +3146,7 @@
         </p:nvSpPr>
         <p:spPr>
           <a:xfrm>
-            <a:off x="640080" y="2468880"/>
+            <a:off x="640080" y="2011680"/>
             <a:ext cx="10881360" cy="1280160"/>
           </a:xfrm>
           <a:prstGeom prst="rect">
@@ -3169,11 +3169,11 @@
               </a:defRPr>
             </a:pPr>
             <a:r>
-              <a:t>Key Insights on Transfer Learning</a:t>
+              <a:t>Transfer Learning vs.</a:t>
             </a:r>
             <a:br/>
             <a:r>
-              <a:t>vs. Training from Scratch</a:t>
+              <a:t>Training from Scratch</a:t>
             </a:r>
           </a:p>
         </p:txBody>
@@ -3186,7 +3186,7 @@
         </p:nvSpPr>
         <p:spPr>
           <a:xfrm>
-            <a:off x="640080" y="3931920"/>
+            <a:off x="640080" y="3474720"/>
             <a:ext cx="2560320" cy="38100"/>
           </a:xfrm>
           <a:prstGeom prst="rect">
@@ -3229,7 +3229,7 @@
         </p:nvSpPr>
         <p:spPr>
           <a:xfrm>
-            <a:off x="640080" y="4297680"/>
+            <a:off x="640080" y="3840480"/>
             <a:ext cx="10881360" cy="365760"/>
           </a:xfrm>
           <a:prstGeom prst="rect">
@@ -3252,7 +3252,7 @@
               </a:defRPr>
             </a:pPr>
             <a:r>
-              <a:t>A Capacity-Matched Empirical Evaluation using ResNet-18</a:t>
+              <a:t>A Capacity-Matched Empirical Evaluation using ResNet-18 on the Intel Image Dataset</a:t>
             </a:r>
           </a:p>
         </p:txBody>
@@ -3265,8 +3265,8 @@
         </p:nvSpPr>
         <p:spPr>
           <a:xfrm>
-            <a:off x="640080" y="5394960"/>
-            <a:ext cx="10881360" cy="365760"/>
+            <a:off x="640080" y="4754880"/>
+            <a:ext cx="10881360" cy="1097280"/>
           </a:xfrm>
           <a:prstGeom prst="rect">
             <a:avLst/>
@@ -3280,15 +3280,23 @@
           <a:lstStyle/>
           <a:p>
             <a:pPr algn="l">
-              <a:defRPr sz="1400" b="1">
-                <a:solidFill>
-                  <a:srgbClr val="0F172A"/>
-                </a:solidFill>
-                <a:latin typeface="Calibri"/>
-              </a:defRPr>
-            </a:pPr>
-            <a:r>
-              <a:t>Shriman Raghav Srinivasan</a:t>
+              <a:defRPr sz="1300" b="0">
+                <a:solidFill>
+                  <a:srgbClr val="334155"/>
+                </a:solidFill>
+                <a:latin typeface="Calibri"/>
+              </a:defRPr>
+            </a:pPr>
+            <a:r>
+              <a:t>Author: Shriman Raghav Srinivasan</a:t>
+            </a:r>
+            <a:br/>
+            <a:r>
+              <a:t>Northeastern University  ·  Khoury College of Computer Sciences</a:t>
+            </a:r>
+            <a:br/>
+            <a:r>
+              <a:t>Advisors: CS 5330 Computer Vision Instruction Team</a:t>
             </a:r>
           </a:p>
         </p:txBody>
@@ -3393,7 +3401,7 @@
                 </a:solidFill>
                 <a:latin typeface="Georgia"/>
               </a:rPr>
-              <a:t>Where this sits</a:t>
+              <a:t>The Confound &amp; Experimental Design</a:t>
             </a:r>
           </a:p>
         </p:txBody>
@@ -3450,7 +3458,7 @@
         <p:spPr>
           <a:xfrm>
             <a:off x="640080" y="1463040"/>
-            <a:ext cx="5029200" cy="4114800"/>
+            <a:ext cx="5029200" cy="4389120"/>
           </a:xfrm>
           <a:prstGeom prst="rect">
             <a:avLst/>
@@ -3472,7 +3480,7 @@
               </a:defRPr>
             </a:pPr>
             <a:r>
-              <a:t>You already have</a:t>
+              <a:t>Motivation &amp; Formulation</a:t>
             </a:r>
           </a:p>
           <a:p>
@@ -3488,7 +3496,7 @@
               </a:defRPr>
             </a:pPr>
             <a:r>
-              <a:t>Transfer learning advantage.</a:t>
+              <a:t>The Core Confound in Transfer Comparisons</a:t>
             </a:r>
           </a:p>
           <a:p>
@@ -3504,13 +3512,13 @@
               </a:defRPr>
             </a:pPr>
             <a:r>
-              <a:t>It consistently outperforms scratch training, but naively comparing a partially frozen model to a full model changes two variables at once.</a:t>
+              <a:t>Standard evaluations contrast a partially frozen, pre-trained network with a fully trained network from scratch. This confounds weight initialization quality with model trainable capacity (parameter count).</a:t>
             </a:r>
           </a:p>
           <a:p>
             <a:pPr>
               <a:spcBef>
-                <a:spcPts val="1800"/>
+                <a:spcPts val="1400"/>
               </a:spcBef>
               <a:defRPr sz="1400" b="1">
                 <a:solidFill>
@@ -3520,7 +3528,7 @@
               </a:defRPr>
             </a:pPr>
             <a:r>
-              <a:t>Trainable capacity confound.</a:t>
+              <a:t>Mathematical Optimization Objective</a:t>
             </a:r>
           </a:p>
           <a:p>
@@ -3536,7 +3544,58 @@
               </a:defRPr>
             </a:pPr>
             <a:r>
-              <a:t>Does the improvement stem from the high quality of pretrained weights, or is it due to having a restricted subset of parameters to optimize?</a:t>
+              <a:t>Let the network parameters θ be split into frozen θf and trainable θt. For all conditions, we optimize θt to minimize cross-entropy loss over N samples:</a:t>
+            </a:r>
+          </a:p>
+          <a:p>
+            <a:pPr>
+              <a:spcBef>
+                <a:spcPts val="800"/>
+              </a:spcBef>
+              <a:spcAft>
+                <a:spcPts val="800"/>
+              </a:spcAft>
+              <a:defRPr sz="1300" b="1">
+                <a:solidFill>
+                  <a:srgbClr val="991B1B"/>
+                </a:solidFill>
+                <a:latin typeface="Georgia"/>
+              </a:defRPr>
+            </a:pPr>
+            <a:r>
+              <a:t>   L(θt) = – (1/N) * Σ [ log p_θ(yi | xi) ]</a:t>
+            </a:r>
+          </a:p>
+          <a:p>
+            <a:pPr>
+              <a:spcBef>
+                <a:spcPts val="800"/>
+              </a:spcBef>
+              <a:defRPr sz="1300" b="1">
+                <a:solidFill>
+                  <a:srgbClr val="0F172A"/>
+                </a:solidFill>
+                <a:latin typeface="Calibri"/>
+              </a:defRPr>
+            </a:pPr>
+            <a:r>
+              <a:t>Isolating Feature Quality</a:t>
+            </a:r>
+          </a:p>
+          <a:p>
+            <a:pPr>
+              <a:spcBef>
+                <a:spcPts val="200"/>
+              </a:spcBef>
+              <a:defRPr sz="1200" b="0">
+                <a:solidFill>
+                  <a:srgbClr val="334155"/>
+                </a:solidFill>
+                <a:latin typeface="Calibri"/>
+              </a:defRPr>
+            </a:pPr>
+            <a:r>
+              <a:t>We hold trainable capacity constant and vary weight initialization to measure the exact contribution of pre-training features.</a:t>
             </a:r>
           </a:p>
         </p:txBody>
@@ -3550,7 +3609,7 @@
         <p:spPr>
           <a:xfrm>
             <a:off x="6217920" y="1463040"/>
-            <a:ext cx="5303520" cy="4114800"/>
+            <a:ext cx="5303520" cy="4389120"/>
           </a:xfrm>
           <a:prstGeom prst="rect">
             <a:avLst/>
@@ -3572,22 +3631,7 @@
               </a:defRPr>
             </a:pPr>
             <a:r>
-              <a:t>The question for today</a:t>
-            </a:r>
-          </a:p>
-          <a:p>
-            <a:pPr>
-              <a:spcBef>
-                <a:spcPts val="800"/>
-              </a:spcBef>
-              <a:defRPr sz="1600" b="1" i="1">
-                <a:solidFill>
-                  <a:srgbClr val="991B1B"/>
-                </a:solidFill>
-              </a:defRPr>
-            </a:pPr>
-            <a:r>
-              <a:t>How do we isolate pretrained feature quality?</a:t>
+              <a:t>Three Training Conditions</a:t>
             </a:r>
           </a:p>
           <a:p>
@@ -3618,13 +3662,13 @@
               <a:t>Pretrained-Frozen (PT-F)</a:t>
             </a:r>
             <a:r>
-              <a:rPr sz="1300">
+              <a:rPr sz="1300" b="0">
                 <a:solidFill>
                   <a:srgbClr val="334155"/>
                 </a:solidFill>
                 <a:latin typeface="Calibri"/>
               </a:rPr>
-              <a:t> — Early layers frozen with ImageNet weights. Only layer4 + fc learn.</a:t>
+              <a:t> — Initialized with ImageNet weights. Early layers (θf) frozen; only the final residual stage (layer4) and classification head (fc) are trainable (θt).</a:t>
             </a:r>
           </a:p>
           <a:p>
@@ -3655,13 +3699,13 @@
               <a:t>Random-Frozen (R-F)</a:t>
             </a:r>
             <a:r>
-              <a:rPr sz="1300">
+              <a:rPr sz="1300" b="0">
                 <a:solidFill>
                   <a:srgbClr val="334155"/>
                 </a:solidFill>
                 <a:latin typeface="Calibri"/>
               </a:rPr>
-              <a:t> — Early layers frozen with random weights. Identical capacity to PT-F.</a:t>
+              <a:t> — Early layers (θf) randomly initialized and frozen. Uses the exact same trainable capacity (θt) as PT-F. Acts as the capacity-matched control.</a:t>
             </a:r>
           </a:p>
           <a:p>
@@ -3692,13 +3736,13 @@
               <a:t>Random-Full (R-FL)</a:t>
             </a:r>
             <a:r>
-              <a:rPr sz="1300">
+              <a:rPr sz="1300" b="0">
                 <a:solidFill>
                   <a:srgbClr val="334155"/>
                 </a:solidFill>
                 <a:latin typeface="Calibri"/>
               </a:rPr>
-              <a:t> — All layers trainable from random init. Standard scratch training baseline.</a:t>
+              <a:t> — Fully trained from scratch. All parameters (both θf and θt) are trainable from random initialization. Serves as the classic capacity baseline.</a:t>
             </a:r>
           </a:p>
         </p:txBody>
@@ -3803,7 +3847,7 @@
                 </a:solidFill>
                 <a:latin typeface="Georgia"/>
               </a:rPr>
-              <a:t>Dataset &amp; Partitioning</a:t>
+              <a:t>Dataset &amp; ResNet-18 Partitioning</a:t>
             </a:r>
           </a:p>
         </p:txBody>
@@ -3860,7 +3904,7 @@
         <p:spPr>
           <a:xfrm>
             <a:off x="640080" y="1463040"/>
-            <a:ext cx="5029200" cy="4114800"/>
+            <a:ext cx="5029200" cy="4389120"/>
           </a:xfrm>
           <a:prstGeom prst="rect">
             <a:avLst/>
@@ -3882,7 +3926,7 @@
               </a:defRPr>
             </a:pPr>
             <a:r>
-              <a:t>The dataset as a unit</a:t>
+              <a:t>Intel Dataset &amp; Preprocessing</a:t>
             </a:r>
           </a:p>
           <a:p>
@@ -3898,7 +3942,7 @@
               </a:defRPr>
             </a:pPr>
             <a:r>
-              <a:t>Intel Image Classification dataset.</a:t>
+              <a:t>Data Distribution &amp; Splits</a:t>
             </a:r>
           </a:p>
           <a:p>
@@ -3914,7 +3958,7 @@
               </a:defRPr>
             </a:pPr>
             <a:r>
-              <a:t>6 scene categories: buildings, forest, glacier, mountain, sea, and street.</a:t>
+              <a:t>Intel Image Classification dataset contains 150×150 px natural scene images across 6 classes: buildings, forest, glacier, mountain, sea, street. Standard training split (14,034 images) is divided into 12,631 train (90%) and 1,403 validation (10%) via class-stratified sampling. Held-out test set contains 3,000 images.</a:t>
             </a:r>
           </a:p>
           <a:p>
@@ -3930,7 +3974,7 @@
               </a:defRPr>
             </a:pPr>
             <a:r>
-              <a:t>Standard splits.</a:t>
+              <a:t>Strict Preprocessing Pipeline</a:t>
             </a:r>
           </a:p>
           <a:p>
@@ -3946,39 +3990,19 @@
               </a:defRPr>
             </a:pPr>
             <a:r>
-              <a:t>14,034 training images (carved into 90% train, 10% stratified val) and 3,000 held-out test images.</a:t>
-            </a:r>
-          </a:p>
-          <a:p>
-            <a:pPr>
-              <a:spcBef>
-                <a:spcPts val="1400"/>
-              </a:spcBef>
-              <a:defRPr sz="1400" b="1">
-                <a:solidFill>
-                  <a:srgbClr val="0F172A"/>
-                </a:solidFill>
-                <a:latin typeface="Calibri"/>
-              </a:defRPr>
-            </a:pPr>
-            <a:r>
-              <a:t>Identical preprocessing.</a:t>
-            </a:r>
-          </a:p>
-          <a:p>
-            <a:pPr>
-              <a:spcBef>
-                <a:spcPts val="200"/>
-              </a:spcBef>
-              <a:defRPr sz="1300" b="0">
-                <a:solidFill>
-                  <a:srgbClr val="334155"/>
-                </a:solidFill>
-                <a:latin typeface="Calibri"/>
-              </a:defRPr>
-            </a:pPr>
-            <a:r>
-              <a:t>Images are resized to 224px, center cropped to 224×224, and normalized using ImageNet channel mean and std.</a:t>
+              <a:t>To match the model architecture requirements and maintain domain consistency:</a:t>
+            </a:r>
+            <a:br/>
+            <a:r>
+              <a:t>• Resize shorter side to 224px (bilinear interpolation)</a:t>
+            </a:r>
+            <a:br/>
+            <a:r>
+              <a:t>• Center-crop to 224 × 224 pixels</a:t>
+            </a:r>
+            <a:br/>
+            <a:r>
+              <a:t>• Per-channel ImageNet normalize: μ = [0.485, 0.456, 0.406], σ = [0.229, 0.224, 0.225]</a:t>
             </a:r>
           </a:p>
         </p:txBody>
@@ -3992,7 +4016,7 @@
         <p:spPr>
           <a:xfrm>
             <a:off x="6217920" y="1463040"/>
-            <a:ext cx="5303520" cy="4114800"/>
+            <a:ext cx="5303520" cy="4389120"/>
           </a:xfrm>
           <a:prstGeom prst="rect">
             <a:avLst/>
@@ -4014,7 +4038,7 @@
               </a:defRPr>
             </a:pPr>
             <a:r>
-              <a:t>Network partitioning</a:t>
+              <a:t>ResNet-18 Partition Boundaries</a:t>
             </a:r>
           </a:p>
           <a:p>
@@ -4042,16 +4066,16 @@
                 </a:solidFill>
                 <a:latin typeface="Calibri"/>
               </a:rPr>
-              <a:t>Frozen Subset (θf)</a:t>
-            </a:r>
-            <a:r>
-              <a:rPr sz="1300">
+              <a:t>Frozen Parameters Block (θf)</a:t>
+            </a:r>
+            <a:r>
+              <a:rPr sz="1300" b="0">
                 <a:solidFill>
                   <a:srgbClr val="334155"/>
                 </a:solidFill>
                 <a:latin typeface="Calibri"/>
               </a:rPr>
-              <a:t> — conv1, bn1, layer1, layer2, layer3 (2.78M params).</a:t>
+              <a:t> — Input convolution (conv1), first batchnorm (bn1), and residual stages layer1, layer2, and layer3. Total parameter count is 2,782,784 (frozen).</a:t>
             </a:r>
           </a:p>
           <a:p>
@@ -4079,16 +4103,16 @@
                 </a:solidFill>
                 <a:latin typeface="Calibri"/>
               </a:rPr>
-              <a:t>Trainable Subset (θt)</a:t>
-            </a:r>
-            <a:r>
-              <a:rPr sz="1300">
+              <a:t>Trainable Parameters Block (θt)</a:t>
+            </a:r>
+            <a:r>
+              <a:rPr sz="1300" b="0">
                 <a:solidFill>
                   <a:srgbClr val="334155"/>
                 </a:solidFill>
                 <a:latin typeface="Calibri"/>
               </a:rPr>
-              <a:t> — layer4 and classification head fc (8.40M params).</a:t>
+              <a:t> — Final residual stage (layer4) and 6-class output fully-connected layer (fc). Total parameter count is 8,396,806 (optimized).</a:t>
             </a:r>
           </a:p>
           <a:p>
@@ -4116,16 +4140,16 @@
                 </a:solidFill>
                 <a:latin typeface="Calibri"/>
               </a:rPr>
-              <a:t>Batch Normalization handling</a:t>
-            </a:r>
-            <a:r>
-              <a:rPr sz="1300">
+              <a:t>Locked Batch Normalization Rule</a:t>
+            </a:r>
+            <a:r>
+              <a:rPr sz="1300" b="0">
                 <a:solidFill>
                   <a:srgbClr val="334155"/>
                 </a:solidFill>
                 <a:latin typeface="Calibri"/>
               </a:rPr>
-              <a:t> — BN layers in θf are explicitly locked in eval() mode. Crucial to prevent statistics drift when weights are frozen.</a:t>
+              <a:t> — BN layers in θf are forced into eval() mode during training. This locks their running mean and variance, preventing update updates from corrupting representation statistics.</a:t>
             </a:r>
           </a:p>
         </p:txBody>
@@ -4230,7 +4254,7 @@
                 </a:solidFill>
                 <a:latin typeface="Georgia"/>
               </a:rPr>
-              <a:t>Test Accuracy Results</a:t>
+              <a:t>Test Performance &amp; Statistics</a:t>
             </a:r>
           </a:p>
         </p:txBody>
@@ -4287,7 +4311,7 @@
         <p:spPr>
           <a:xfrm>
             <a:off x="640080" y="1463040"/>
-            <a:ext cx="5029200" cy="4114800"/>
+            <a:ext cx="5029200" cy="4389120"/>
           </a:xfrm>
           <a:prstGeom prst="rect">
             <a:avLst/>
@@ -4309,7 +4333,7 @@
               </a:defRPr>
             </a:pPr>
             <a:r>
-              <a:t>Performance summary</a:t>
+              <a:t>Experimental Metrics</a:t>
             </a:r>
           </a:p>
           <a:p>
@@ -4325,7 +4349,7 @@
               </a:defRPr>
             </a:pPr>
             <a:r>
-              <a:t>Pretrained-Frozen (PT-F) is the clear winner.</a:t>
+              <a:t>Empirical Test Results (Mean ± Std Dev)</a:t>
             </a:r>
           </a:p>
           <a:p>
@@ -4341,15 +4365,15 @@
               </a:defRPr>
             </a:pPr>
             <a:r>
-              <a:t>Achieves a mean test accuracy of 93.27% ± 0.23% across all random seeds.</a:t>
+              <a:t>Evaluated on the held-out test split of 3,000 images across 3 random seeds (42, 100, 2026):</a:t>
             </a:r>
           </a:p>
           <a:p>
             <a:pPr>
               <a:spcBef>
-                <a:spcPts val="1400"/>
+                <a:spcPts val="8640"/>
               </a:spcBef>
-              <a:defRPr sz="1400" b="1">
+              <a:defRPr sz="1300" b="1">
                 <a:solidFill>
                   <a:srgbClr val="0F172A"/>
                 </a:solidFill>
@@ -4357,7 +4381,7 @@
               </a:defRPr>
             </a:pPr>
             <a:r>
-              <a:t>Random-Full (R-FL) scratch baseline.</a:t>
+              <a:t>Key Statistical Takeaway</a:t>
             </a:r>
           </a:p>
           <a:p>
@@ -4365,7 +4389,7 @@
               <a:spcBef>
                 <a:spcPts val="200"/>
               </a:spcBef>
-              <a:defRPr sz="1300" b="0">
+              <a:defRPr sz="1200" b="0">
                 <a:solidFill>
                   <a:srgbClr val="334155"/>
                 </a:solidFill>
@@ -4373,61 +4397,253 @@
               </a:defRPr>
             </a:pPr>
             <a:r>
-              <a:t>Achieves a mean test accuracy of 84.69% ± 1.87% when all layers are trained.</a:t>
-            </a:r>
-          </a:p>
-          <a:p>
-            <a:pPr>
-              <a:spcBef>
-                <a:spcPts val="1400"/>
-              </a:spcBef>
-              <a:defRPr sz="1400" b="1">
-                <a:solidFill>
-                  <a:srgbClr val="0F172A"/>
-                </a:solidFill>
-                <a:latin typeface="Calibri"/>
-              </a:defRPr>
-            </a:pPr>
-            <a:r>
-              <a:t>Random-Frozen (R-F) capacity control.</a:t>
-            </a:r>
-          </a:p>
-          <a:p>
-            <a:pPr>
-              <a:spcBef>
-                <a:spcPts val="200"/>
-              </a:spcBef>
-              <a:defRPr sz="1300" b="0">
-                <a:solidFill>
-                  <a:srgbClr val="334155"/>
-                </a:solidFill>
-                <a:latin typeface="Calibri"/>
-              </a:defRPr>
-            </a:pPr>
-            <a:r>
-              <a:t>Achieves only 66.54% ± 4.04%, stagnating early due to arbitrary frozen feature space.</a:t>
-            </a:r>
-          </a:p>
-          <a:p>
-            <a:pPr>
-              <a:spcBef>
-                <a:spcPts val="1400"/>
-              </a:spcBef>
-              <a:defRPr sz="1200" b="1">
-                <a:solidFill>
-                  <a:srgbClr val="991B1B"/>
-                </a:solidFill>
-              </a:defRPr>
-            </a:pPr>
-            <a:r>
-              <a:t>Matched capacity gap: +26.73% accuracy purely due to pretrained weight quality (PT-F vs. R-F).</a:t>
-            </a:r>
-          </a:p>
-        </p:txBody>
-      </p:sp>
+              <a:t>PT-F outperforms R-F by 26.73% absolute accuracy, isolating the vast superiority of ImageNet weights under identical model capacity. PT-F also beats R-FL (fully trainable scratch baseline) by 8.58%, illustrating that pre-training functions as a stronger regularizer than network scale alone.</a:t>
+            </a:r>
+          </a:p>
+        </p:txBody>
+      </p:sp>
+      <p:graphicFrame>
+        <p:nvGraphicFramePr>
+          <p:cNvPr id="5" name="Table 4"/>
+          <p:cNvGraphicFramePr>
+            <a:graphicFrameLocks noGrp="1"/>
+          </p:cNvGraphicFramePr>
+          <p:nvPr/>
+        </p:nvGraphicFramePr>
+        <p:xfrm>
+          <a:off x="640080" y="2468880"/>
+          <a:ext cx="5029200" cy="1280160"/>
+        </p:xfrm>
+        <a:graphic>
+          <a:graphicData uri="http://schemas.openxmlformats.org/drawingml/2006/table">
+            <a:tbl>
+              <a:tblPr firstRow="1" bandRow="1">
+                <a:tableStyleId>{5C22544A-7EE6-4342-B048-85BDC9FD1C3A}</a:tableStyleId>
+              </a:tblPr>
+              <a:tblGrid>
+                <a:gridCol w="2103120"/>
+                <a:gridCol w="1463040"/>
+                <a:gridCol w="1463040"/>
+              </a:tblGrid>
+              <a:tr h="320040">
+                <a:tc>
+                  <a:txBody>
+                    <a:bodyPr/>
+                    <a:lstStyle/>
+                    <a:p>
+                      <a:pPr>
+                        <a:defRPr sz="1100" b="1">
+                          <a:solidFill>
+                            <a:srgbClr val="0F172A"/>
+                          </a:solidFill>
+                        </a:defRPr>
+                      </a:pPr>
+                      <a:r>
+                        <a:t>Condition</a:t>
+                      </a:r>
+                    </a:p>
+                  </a:txBody>
+                  <a:tcPr/>
+                </a:tc>
+                <a:tc>
+                  <a:txBody>
+                    <a:bodyPr/>
+                    <a:lstStyle/>
+                    <a:p>
+                      <a:pPr>
+                        <a:defRPr sz="1100" b="1">
+                          <a:solidFill>
+                            <a:srgbClr val="0F172A"/>
+                          </a:solidFill>
+                        </a:defRPr>
+                      </a:pPr>
+                      <a:r>
+                        <a:t>Mean Test Acc</a:t>
+                      </a:r>
+                    </a:p>
+                  </a:txBody>
+                  <a:tcPr/>
+                </a:tc>
+                <a:tc>
+                  <a:txBody>
+                    <a:bodyPr/>
+                    <a:lstStyle/>
+                    <a:p>
+                      <a:pPr>
+                        <a:defRPr sz="1100" b="1">
+                          <a:solidFill>
+                            <a:srgbClr val="0F172A"/>
+                          </a:solidFill>
+                        </a:defRPr>
+                      </a:pPr>
+                      <a:r>
+                        <a:t>Std Dev</a:t>
+                      </a:r>
+                    </a:p>
+                  </a:txBody>
+                  <a:tcPr/>
+                </a:tc>
+              </a:tr>
+              <a:tr h="320040">
+                <a:tc>
+                  <a:txBody>
+                    <a:bodyPr/>
+                    <a:lstStyle/>
+                    <a:p>
+                      <a:pPr>
+                        <a:defRPr sz="1100"/>
+                      </a:pPr>
+                      <a:r>
+                        <a:t>Pretrained-Frozen</a:t>
+                      </a:r>
+                    </a:p>
+                  </a:txBody>
+                  <a:tcPr/>
+                </a:tc>
+                <a:tc>
+                  <a:txBody>
+                    <a:bodyPr/>
+                    <a:lstStyle/>
+                    <a:p>
+                      <a:pPr>
+                        <a:defRPr sz="1100" b="1">
+                          <a:solidFill>
+                            <a:srgbClr val="991B1B"/>
+                          </a:solidFill>
+                        </a:defRPr>
+                      </a:pPr>
+                      <a:r>
+                        <a:t>93.27%</a:t>
+                      </a:r>
+                    </a:p>
+                  </a:txBody>
+                  <a:tcPr/>
+                </a:tc>
+                <a:tc>
+                  <a:txBody>
+                    <a:bodyPr/>
+                    <a:lstStyle/>
+                    <a:p>
+                      <a:pPr>
+                        <a:defRPr sz="1100"/>
+                      </a:pPr>
+                      <a:r>
+                        <a:t>±0.23%</a:t>
+                      </a:r>
+                    </a:p>
+                  </a:txBody>
+                  <a:tcPr/>
+                </a:tc>
+              </a:tr>
+              <a:tr h="320040">
+                <a:tc>
+                  <a:txBody>
+                    <a:bodyPr/>
+                    <a:lstStyle/>
+                    <a:p>
+                      <a:pPr>
+                        <a:defRPr sz="1100"/>
+                      </a:pPr>
+                      <a:r>
+                        <a:t>Random-Full</a:t>
+                      </a:r>
+                    </a:p>
+                  </a:txBody>
+                  <a:tcPr/>
+                </a:tc>
+                <a:tc>
+                  <a:txBody>
+                    <a:bodyPr/>
+                    <a:lstStyle/>
+                    <a:p>
+                      <a:pPr>
+                        <a:defRPr sz="1100" b="1">
+                          <a:solidFill>
+                            <a:srgbClr val="0F172A"/>
+                          </a:solidFill>
+                        </a:defRPr>
+                      </a:pPr>
+                      <a:r>
+                        <a:t>84.69%</a:t>
+                      </a:r>
+                    </a:p>
+                  </a:txBody>
+                  <a:tcPr/>
+                </a:tc>
+                <a:tc>
+                  <a:txBody>
+                    <a:bodyPr/>
+                    <a:lstStyle/>
+                    <a:p>
+                      <a:pPr>
+                        <a:defRPr sz="1100"/>
+                      </a:pPr>
+                      <a:r>
+                        <a:t>±1.87%</a:t>
+                      </a:r>
+                    </a:p>
+                  </a:txBody>
+                  <a:tcPr/>
+                </a:tc>
+              </a:tr>
+              <a:tr h="320040">
+                <a:tc>
+                  <a:txBody>
+                    <a:bodyPr/>
+                    <a:lstStyle/>
+                    <a:p>
+                      <a:pPr>
+                        <a:defRPr sz="1100"/>
+                      </a:pPr>
+                      <a:r>
+                        <a:t>Random-Frozen</a:t>
+                      </a:r>
+                    </a:p>
+                  </a:txBody>
+                  <a:tcPr/>
+                </a:tc>
+                <a:tc>
+                  <a:txBody>
+                    <a:bodyPr/>
+                    <a:lstStyle/>
+                    <a:p>
+                      <a:pPr>
+                        <a:defRPr sz="1100" b="1">
+                          <a:solidFill>
+                            <a:srgbClr val="0F172A"/>
+                          </a:solidFill>
+                        </a:defRPr>
+                      </a:pPr>
+                      <a:r>
+                        <a:t>66.54%</a:t>
+                      </a:r>
+                    </a:p>
+                  </a:txBody>
+                  <a:tcPr/>
+                </a:tc>
+                <a:tc>
+                  <a:txBody>
+                    <a:bodyPr/>
+                    <a:lstStyle/>
+                    <a:p>
+                      <a:pPr>
+                        <a:defRPr sz="1100"/>
+                      </a:pPr>
+                      <a:r>
+                        <a:t>±4.04%</a:t>
+                      </a:r>
+                    </a:p>
+                  </a:txBody>
+                  <a:tcPr/>
+                </a:tc>
+              </a:tr>
+            </a:tbl>
+          </a:graphicData>
+        </a:graphic>
+      </p:graphicFrame>
       <p:pic>
         <p:nvPicPr>
-          <p:cNvPr id="5" name="Picture 4" descr="bar.png"/>
+          <p:cNvPr id="6" name="Picture 5" descr="bar.png"/>
           <p:cNvPicPr>
             <a:picLocks noChangeAspect="1"/>
           </p:cNvPicPr>
@@ -4451,7 +4667,7 @@
       </p:pic>
       <p:sp>
         <p:nvSpPr>
-          <p:cNvPr id="6" name="TextBox 5"/>
+          <p:cNvPr id="7" name="TextBox 6"/>
           <p:cNvSpPr txBox="1"/>
           <p:nvPr/>
         </p:nvSpPr>
@@ -4549,7 +4765,7 @@
                 </a:solidFill>
                 <a:latin typeface="Georgia"/>
               </a:rPr>
-              <a:t>Training Dynamics</a:t>
+              <a:t>Training Dynamics &amp; Optimization</a:t>
             </a:r>
           </a:p>
         </p:txBody>
@@ -4630,7 +4846,7 @@
         <p:spPr>
           <a:xfrm>
             <a:off x="7315200" y="1463040"/>
-            <a:ext cx="4206240" cy="4114800"/>
+            <a:ext cx="4206240" cy="4389120"/>
           </a:xfrm>
           <a:prstGeom prst="rect">
             <a:avLst/>
@@ -4652,7 +4868,7 @@
               </a:defRPr>
             </a:pPr>
             <a:r>
-              <a:t>Convergence &amp; speed</a:t>
+              <a:t>Optimization &amp; Speed</a:t>
             </a:r>
           </a:p>
           <a:p>
@@ -4660,7 +4876,7 @@
               <a:spcBef>
                 <a:spcPts val="800"/>
               </a:spcBef>
-              <a:defRPr sz="1400" b="1">
+              <a:defRPr sz="1300" b="1">
                 <a:solidFill>
                   <a:srgbClr val="0F172A"/>
                 </a:solidFill>
@@ -4668,7 +4884,7 @@
               </a:defRPr>
             </a:pPr>
             <a:r>
-              <a:t>Pretraining yields instant start.</a:t>
+              <a:t>Training Hyperparameters</a:t>
             </a:r>
           </a:p>
           <a:p>
@@ -4676,7 +4892,7 @@
               <a:spcBef>
                 <a:spcPts val="200"/>
               </a:spcBef>
-              <a:defRPr sz="1300" b="0">
+              <a:defRPr sz="1200" b="0">
                 <a:solidFill>
                   <a:srgbClr val="334155"/>
                 </a:solidFill>
@@ -4684,15 +4900,23 @@
               </a:defRPr>
             </a:pPr>
             <a:r>
-              <a:t>PT-F begins above 90% validation accuracy at epoch 1 and converges rapidly (mean: 8.0 epochs / 1.7 minutes).</a:t>
+              <a:t>• Optimizer: SGD with momentum = 0.9</a:t>
+            </a:r>
+            <a:br/>
+            <a:r>
+              <a:t>• Weight Decay: 1 × 10⁻⁴ | Learning Rate: 1 × 10⁻³</a:t>
+            </a:r>
+            <a:br/>
+            <a:r>
+              <a:t>• Batch Size: 32 | Validation patience = 5 epochs</a:t>
             </a:r>
           </a:p>
           <a:p>
             <a:pPr>
               <a:spcBef>
-                <a:spcPts val="1400"/>
+                <a:spcPts val="1200"/>
               </a:spcBef>
-              <a:defRPr sz="1400" b="1">
+              <a:defRPr sz="1300" b="1">
                 <a:solidFill>
                   <a:srgbClr val="0F172A"/>
                 </a:solidFill>
@@ -4700,7 +4924,7 @@
               </a:defRPr>
             </a:pPr>
             <a:r>
-              <a:t>Scratch is slow and expensive.</a:t>
+              <a:t>Convergence Epochs &amp; Compute Duration</a:t>
             </a:r>
           </a:p>
           <a:p>
@@ -4708,7 +4932,7 @@
               <a:spcBef>
                 <a:spcPts val="200"/>
               </a:spcBef>
-              <a:defRPr sz="1300" b="0">
+              <a:defRPr sz="1200" b="0">
                 <a:solidFill>
                   <a:srgbClr val="334155"/>
                 </a:solidFill>
@@ -4716,15 +4940,23 @@
               </a:defRPr>
             </a:pPr>
             <a:r>
-              <a:t>R-FL requires a mean of 15.0 epochs / 7.1 minutes to converge — twice as many epochs and 4× more training time.</a:t>
+              <a:t>• PT-Frozen: Converges in 8.0 epochs mean (102.5s duration). Starts immediately at high val accuracy (&gt;90% in epoch 1).</a:t>
+            </a:r>
+            <a:br/>
+            <a:r>
+              <a:t>• Random-Frozen: Converges in 8.7 epochs mean (112.8s duration) but plateaus at low validation accuracy (67.8%).</a:t>
+            </a:r>
+            <a:br/>
+            <a:r>
+              <a:t>• Random-Full: Requires 15.0 epochs mean (425.7s duration). Needs nearly twice as many epochs and 4× more compute time.</a:t>
             </a:r>
           </a:p>
           <a:p>
             <a:pPr>
               <a:spcBef>
-                <a:spcPts val="1400"/>
+                <a:spcPts val="1200"/>
               </a:spcBef>
-              <a:defRPr sz="1400" b="1">
+              <a:defRPr sz="1300" b="1">
                 <a:solidFill>
                   <a:srgbClr val="0F172A"/>
                 </a:solidFill>
@@ -4732,7 +4964,7 @@
               </a:defRPr>
             </a:pPr>
             <a:r>
-              <a:t>Random-frozen bottleneck.</a:t>
+              <a:t>Early Stopping Behavior</a:t>
             </a:r>
           </a:p>
           <a:p>
@@ -4740,7 +4972,7 @@
               <a:spcBef>
                 <a:spcPts val="200"/>
               </a:spcBef>
-              <a:defRPr sz="1300" b="0">
+              <a:defRPr sz="1200" b="0">
                 <a:solidFill>
                   <a:srgbClr val="334155"/>
                 </a:solidFill>
@@ -4748,7 +4980,7 @@
               </a:defRPr>
             </a:pPr>
             <a:r>
-              <a:t>R-F plateaus quickly (mean: 8.7 epochs / 1.9 minutes) because learning cannot progress beyond arbitrary linear layers.</a:t>
+              <a:t>Early stopping on validation loss successfully prevents overfitting. R-FL continues to improve steadily but exhibits high seed variance, whereas PT-F converges to a flat validation trajectory immediately.</a:t>
             </a:r>
           </a:p>
         </p:txBody>
@@ -4853,7 +5085,7 @@
                 </a:solidFill>
                 <a:latin typeface="Georgia"/>
               </a:rPr>
-              <a:t>Confusion &amp; Class F1</a:t>
+              <a:t>Confusion &amp; Class F1 Analysis</a:t>
             </a:r>
           </a:p>
         </p:txBody>
@@ -4934,7 +5166,7 @@
         <p:spPr>
           <a:xfrm>
             <a:off x="7315200" y="1463040"/>
-            <a:ext cx="4206240" cy="4114800"/>
+            <a:ext cx="4206240" cy="4389120"/>
           </a:xfrm>
           <a:prstGeom prst="rect">
             <a:avLst/>
@@ -4956,7 +5188,7 @@
               </a:defRPr>
             </a:pPr>
             <a:r>
-              <a:t>Per-class findings</a:t>
+              <a:t>Per-class Findings</a:t>
             </a:r>
           </a:p>
           <a:p>
@@ -4964,7 +5196,7 @@
               <a:spcBef>
                 <a:spcPts val="800"/>
               </a:spcBef>
-              <a:defRPr sz="1400" b="1">
+              <a:defRPr sz="1300" b="1">
                 <a:solidFill>
                   <a:srgbClr val="0F172A"/>
                 </a:solidFill>
@@ -4972,7 +5204,7 @@
               </a:defRPr>
             </a:pPr>
             <a:r>
-              <a:t>Glacier vs. Mountain confusion.</a:t>
+              <a:t>Glacier vs. Mountain Confusion</a:t>
             </a:r>
           </a:p>
           <a:p>
@@ -4980,7 +5212,7 @@
               <a:spcBef>
                 <a:spcPts val="200"/>
               </a:spcBef>
-              <a:defRPr sz="1300" b="0">
+              <a:defRPr sz="1200" b="0">
                 <a:solidFill>
                   <a:srgbClr val="334155"/>
                 </a:solidFill>
@@ -4988,15 +5220,15 @@
               </a:defRPr>
             </a:pPr>
             <a:r>
-              <a:t>Shared visual signatures (snow, rock textures) lead to major mutual confusion in all conditions.</a:t>
+              <a:t>Glaciers and mountains exhibit high visual similarity (white snow, jagged grey rock textures), causing major mutual confusion across all conditions. Representative PT-F seed misclassifies 41 mountain images as glacier and 55 glacier images as mountain.</a:t>
             </a:r>
           </a:p>
           <a:p>
             <a:pPr>
               <a:spcBef>
-                <a:spcPts val="1400"/>
+                <a:spcPts val="1200"/>
               </a:spcBef>
-              <a:defRPr sz="1400" b="1">
+              <a:defRPr sz="1300" b="1">
                 <a:solidFill>
                   <a:srgbClr val="0F172A"/>
                 </a:solidFill>
@@ -5004,7 +5236,7 @@
               </a:defRPr>
             </a:pPr>
             <a:r>
-              <a:t>Buildings vs. Street confusion.</a:t>
+              <a:t>Buildings vs. Street Confusion</a:t>
             </a:r>
           </a:p>
           <a:p>
@@ -5012,7 +5244,7 @@
               <a:spcBef>
                 <a:spcPts val="200"/>
               </a:spcBef>
-              <a:defRPr sz="1300" b="0">
+              <a:defRPr sz="1200" b="0">
                 <a:solidFill>
                   <a:srgbClr val="334155"/>
                 </a:solidFill>
@@ -5020,15 +5252,15 @@
               </a:defRPr>
             </a:pPr>
             <a:r>
-              <a:t>Urban context overlap makes these classes prone to mutual misclassifications.</a:t>
+              <a:t>Urban images frequently co-occur (streets contain buildings in the background), leading to high confusion rates (29 street images classified as buildings).</a:t>
             </a:r>
           </a:p>
           <a:p>
             <a:pPr>
               <a:spcBef>
-                <a:spcPts val="1400"/>
+                <a:spcPts val="1200"/>
               </a:spcBef>
-              <a:defRPr sz="1400" b="1">
+              <a:defRPr sz="1300" b="1">
                 <a:solidFill>
                   <a:srgbClr val="0F172A"/>
                 </a:solidFill>
@@ -5036,7 +5268,7 @@
               </a:defRPr>
             </a:pPr>
             <a:r>
-              <a:t>Distinct classes excel.</a:t>
+              <a:t>Strongest Categories</a:t>
             </a:r>
           </a:p>
           <a:p>
@@ -5044,7 +5276,7 @@
               <a:spcBef>
                 <a:spcPts val="200"/>
               </a:spcBef>
-              <a:defRPr sz="1300" b="0">
+              <a:defRPr sz="1200" b="0">
                 <a:solidFill>
                   <a:srgbClr val="334155"/>
                 </a:solidFill>
@@ -5052,7 +5284,39 @@
               </a:defRPr>
             </a:pPr>
             <a:r>
-              <a:t>Forest consistently achieves the highest F1 score due to strong, uniform color and texture cues.</a:t>
+              <a:t>Forest has the highest F1 score (PT-F: 99.8%) due to distinct green hue and texture patterns. Sea achieves excellent F1 (96.5%).</a:t>
+            </a:r>
+          </a:p>
+          <a:p>
+            <a:pPr>
+              <a:spcBef>
+                <a:spcPts val="1200"/>
+              </a:spcBef>
+              <a:defRPr sz="1300" b="1">
+                <a:solidFill>
+                  <a:srgbClr val="0F172A"/>
+                </a:solidFill>
+                <a:latin typeface="Calibri"/>
+              </a:defRPr>
+            </a:pPr>
+            <a:r>
+              <a:t>Scratch training F1 drop</a:t>
+            </a:r>
+          </a:p>
+          <a:p>
+            <a:pPr>
+              <a:spcBef>
+                <a:spcPts val="200"/>
+              </a:spcBef>
+              <a:defRPr sz="1200" b="0">
+                <a:solidFill>
+                  <a:srgbClr val="334155"/>
+                </a:solidFill>
+                <a:latin typeface="Calibri"/>
+              </a:defRPr>
+            </a:pPr>
+            <a:r>
+              <a:t>R-FL achieves lower F1 scores across the board (Forest: 94.8%, Glacier: 73.5%, Mountain: 78.3%), proving that scratch features struggle with subtle boundary details.</a:t>
             </a:r>
           </a:p>
         </p:txBody>
@@ -5157,7 +5421,7 @@
                 </a:solidFill>
                 <a:latin typeface="Georgia"/>
               </a:rPr>
-              <a:t>Key Takeaways</a:t>
+              <a:t>Discussion &amp; Conclusions</a:t>
             </a:r>
           </a:p>
         </p:txBody>
@@ -5214,7 +5478,7 @@
         <p:spPr>
           <a:xfrm>
             <a:off x="640080" y="1463040"/>
-            <a:ext cx="5029200" cy="4114800"/>
+            <a:ext cx="5029200" cy="4389120"/>
           </a:xfrm>
           <a:prstGeom prst="rect">
             <a:avLst/>
@@ -5236,7 +5500,7 @@
               </a:defRPr>
             </a:pPr>
             <a:r>
-              <a:t>Conclusions</a:t>
+              <a:t>Scientific Discussion</a:t>
             </a:r>
           </a:p>
           <a:p>
@@ -5252,7 +5516,7 @@
               </a:defRPr>
             </a:pPr>
             <a:r>
-              <a:t>Pretrained features drive transfer success.</a:t>
+              <a:t>Pretraining Quality vs. Trainable Capacity</a:t>
             </a:r>
           </a:p>
           <a:p>
@@ -5268,7 +5532,7 @@
               </a:defRPr>
             </a:pPr>
             <a:r>
-              <a:t>The capacity control (R-F) confirms that restricting trainable parameter space is not what makes transfer learning succeed. Pretrained feature quality is the primary driver.</a:t>
+              <a:t>The capacity control (R-F) establishes that freezing early layers restricts trainable capacity, leading to poor scratch performance (+26.73% accuracy gap). In contrast, pre-trained weights (PT-F) furnish structured, highly generalizable features (edges, textures, shapes) that adapt seamlessly.</a:t>
             </a:r>
           </a:p>
           <a:p>
@@ -5284,7 +5548,7 @@
               </a:defRPr>
             </a:pPr>
             <a:r>
-              <a:t>Resource efficiency.</a:t>
+              <a:t>Revisiting Literature (He et al. 2019)</a:t>
             </a:r>
           </a:p>
           <a:p>
@@ -5300,7 +5564,7 @@
               </a:defRPr>
             </a:pPr>
             <a:r>
-              <a:t>Transfer learning yields +8.58% higher accuracy compared to training from scratch (R-FL) while converging in nearly 4× less compute time.</a:t>
+              <a:t>He et al. showed that training from scratch can match pre-training with enough time and data. Our results confirm that under a tight training patience budget and modest target data size, transfer learning is highly essential, outperforming scratch by 8.58% in 4× less time.</a:t>
             </a:r>
           </a:p>
         </p:txBody>
@@ -5314,7 +5578,7 @@
         <p:spPr>
           <a:xfrm>
             <a:off x="6217920" y="1463040"/>
-            <a:ext cx="5303520" cy="4114800"/>
+            <a:ext cx="5303520" cy="4389120"/>
           </a:xfrm>
           <a:prstGeom prst="rect">
             <a:avLst/>
@@ -5336,7 +5600,7 @@
               </a:defRPr>
             </a:pPr>
             <a:r>
-              <a:t>Future directions</a:t>
+              <a:t>Future Work &amp; Summary</a:t>
             </a:r>
           </a:p>
           <a:p>
@@ -5364,16 +5628,16 @@
                 </a:solidFill>
                 <a:latin typeface="Calibri"/>
               </a:rPr>
-              <a:t>Vary frozen boundary</a:t>
-            </a:r>
-            <a:r>
-              <a:rPr sz="1300">
+              <a:t>Vary the frozen boundary</a:t>
+            </a:r>
+            <a:r>
+              <a:rPr sz="1300" b="0">
                 <a:solidFill>
                   <a:srgbClr val="334155"/>
                 </a:solidFill>
                 <a:latin typeface="Calibri"/>
               </a:rPr>
-              <a:t> — Test fine-tuning with fewer or more frozen layers (e.g. freeze only layer1-2).</a:t>
+              <a:t> — Test fine-tuning with fewer/more frozen layers (e.g. freeze layer1-2) to investigate where task-specific representations begin.</a:t>
             </a:r>
           </a:p>
           <a:p>
@@ -5401,16 +5665,16 @@
                 </a:solidFill>
                 <a:latin typeface="Calibri"/>
               </a:rPr>
-              <a:t>Scale model scale</a:t>
-            </a:r>
-            <a:r>
-              <a:rPr sz="1300">
+              <a:t>Evaluate larger backbones</a:t>
+            </a:r>
+            <a:r>
+              <a:rPr sz="1300" b="0">
                 <a:solidFill>
                   <a:srgbClr val="334155"/>
                 </a:solidFill>
                 <a:latin typeface="Calibri"/>
               </a:rPr>
-              <a:t> — Evaluate capacity-matched controls on deeper networks (ResNet-50) or ViT backbones.</a:t>
+              <a:t> — Extend this capacity-matched analysis to deeper models (ResNet-50) or non-convolutional backbones (Vision Transformers).</a:t>
             </a:r>
           </a:p>
           <a:p>
@@ -5441,13 +5705,13 @@
               <a:t>Progressive unfreezing</a:t>
             </a:r>
             <a:r>
-              <a:rPr sz="1300">
+              <a:rPr sz="1300" b="0">
                 <a:solidFill>
                   <a:srgbClr val="334155"/>
                 </a:solidFill>
                 <a:latin typeface="Calibri"/>
               </a:rPr>
-              <a:t> — Gradually unfreeze earlier layers with a smaller learning rate as training progresses.</a:t>
+              <a:t> — Apply learning rate warmup and gradually unlock layers from back to front during training to avoid representation collapse.</a:t>
             </a:r>
           </a:p>
           <a:p>
@@ -5475,16 +5739,16 @@
                 </a:solidFill>
                 <a:latin typeface="Calibri"/>
               </a:rPr>
-              <a:t>Data augmentation</a:t>
-            </a:r>
-            <a:r>
-              <a:rPr sz="1300">
+              <a:t>Advanced augmentations</a:t>
+            </a:r>
+            <a:r>
+              <a:rPr sz="1300" b="0">
                 <a:solidFill>
                   <a:srgbClr val="334155"/>
                 </a:solidFill>
                 <a:latin typeface="Calibri"/>
               </a:rPr>
-              <a:t> — Investigate if heavy augmentations can close the scratch training accuracy gap.</a:t>
+              <a:t> — Examine if severe augmentations (MixUp, RandAugment) can help scratch models (R-FL) close the generalization gap.</a:t>
             </a:r>
           </a:p>
         </p:txBody>

</xml_diff>